<commit_message>
chore: refresh database systems chapter 2 exercises
</commit_message>
<xml_diff>
--- a/data/DB시스템/2장_연습문제_풀이.pptx
+++ b/data/DB시스템/2장_연습문제_풀이.pptx
@@ -26074,7 +26074,7 @@
         <p:spPr>
           <a:xfrm>
             <a:off x="457200" y="2468880"/>
-            <a:ext cx="8229600" cy="2578608"/>
+            <a:ext cx="8229600" cy="2446020"/>
           </a:xfrm>
           <a:prstGeom prst="rect">
             <a:avLst/>
@@ -26101,7 +26101,7 @@
         <p:spPr>
           <a:xfrm>
             <a:off x="457200" y="2468880"/>
-            <a:ext cx="73152" cy="2578608"/>
+            <a:ext cx="73152" cy="2446020"/>
           </a:xfrm>
           <a:prstGeom prst="rect">
             <a:avLst/>
@@ -26184,7 +26184,7 @@
         <p:spPr>
           <a:xfrm>
             <a:off x="731520" y="2880360"/>
-            <a:ext cx="7680960" cy="2075688"/>
+            <a:ext cx="7680960" cy="1737360"/>
           </a:xfrm>
           <a:prstGeom prst="rect">
             <a:avLst/>
@@ -27778,7 +27778,7 @@
         <p:spPr>
           <a:xfrm>
             <a:off x="457200" y="2788920"/>
-            <a:ext cx="8229600" cy="2286000"/>
+            <a:ext cx="8229600" cy="2080260"/>
           </a:xfrm>
           <a:prstGeom prst="rect">
             <a:avLst/>
@@ -27805,7 +27805,7 @@
         <p:spPr>
           <a:xfrm>
             <a:off x="457200" y="2788920"/>
-            <a:ext cx="73152" cy="2286000"/>
+            <a:ext cx="73152" cy="2080260"/>
           </a:xfrm>
           <a:prstGeom prst="rect">
             <a:avLst/>
@@ -27888,7 +27888,7 @@
         <p:spPr>
           <a:xfrm>
             <a:off x="731520" y="3200400"/>
-            <a:ext cx="7680960" cy="1783080"/>
+            <a:ext cx="7680960" cy="1440180"/>
           </a:xfrm>
           <a:prstGeom prst="rect">
             <a:avLst/>
@@ -28649,7 +28649,7 @@
         <p:spPr>
           <a:xfrm>
             <a:off x="457200" y="2788920"/>
-            <a:ext cx="8229600" cy="2871216"/>
+            <a:ext cx="8229600" cy="2125980"/>
           </a:xfrm>
           <a:prstGeom prst="rect">
             <a:avLst/>
@@ -28676,7 +28676,7 @@
         <p:spPr>
           <a:xfrm>
             <a:off x="457200" y="2788920"/>
-            <a:ext cx="73152" cy="2871216"/>
+            <a:ext cx="73152" cy="2125980"/>
           </a:xfrm>
           <a:prstGeom prst="rect">
             <a:avLst/>
@@ -28759,7 +28759,7 @@
         <p:spPr>
           <a:xfrm>
             <a:off x="731520" y="3200400"/>
-            <a:ext cx="7680960" cy="2368296"/>
+            <a:ext cx="7680960" cy="1569720"/>
           </a:xfrm>
           <a:prstGeom prst="rect">
             <a:avLst/>
@@ -30400,7 +30400,7 @@
         <p:spPr>
           <a:xfrm>
             <a:off x="457200" y="2468880"/>
-            <a:ext cx="8229600" cy="2871216"/>
+            <a:ext cx="8229600" cy="2400300"/>
           </a:xfrm>
           <a:prstGeom prst="rect">
             <a:avLst/>
@@ -30427,7 +30427,7 @@
         <p:spPr>
           <a:xfrm>
             <a:off x="457200" y="2468880"/>
-            <a:ext cx="73152" cy="2871216"/>
+            <a:ext cx="73152" cy="2400300"/>
           </a:xfrm>
           <a:prstGeom prst="rect">
             <a:avLst/>
@@ -30510,7 +30510,7 @@
         <p:spPr>
           <a:xfrm>
             <a:off x="731520" y="2880360"/>
-            <a:ext cx="7680960" cy="2368296"/>
+            <a:ext cx="7680960" cy="1729740"/>
           </a:xfrm>
           <a:prstGeom prst="rect">
             <a:avLst/>

</xml_diff>